<commit_message>
plots for v3 of MS
</commit_message>
<xml_diff>
--- a/figure8/fig8_prelim.pptx
+++ b/figure8/fig8_prelim.pptx
@@ -6,6 +6,7 @@
   </p:sldMasterIdLst>
   <p:sldIdLst>
     <p:sldId id="256" r:id="rId2"/>
+    <p:sldId id="257" r:id="rId3"/>
   </p:sldIdLst>
   <p:sldSz cx="12192000" cy="6858000"/>
   <p:notesSz cx="6858000" cy="9144000"/>
@@ -104,6 +105,11 @@
       </a:defRPr>
     </a:lvl9pPr>
   </p:defaultTextStyle>
+  <p:extLst>
+    <p:ext uri="{EFAFB233-063F-42B5-8137-9DF3F51BA10A}">
+      <p15:sldGuideLst xmlns:p15="http://schemas.microsoft.com/office/powerpoint/2012/main"/>
+    </p:ext>
+  </p:extLst>
 </p:presentation>
 </file>
 
@@ -254,7 +260,7 @@
           <a:p>
             <a:fld id="{FBCC2567-9977-4F83-A8E1-848787B3FEC4}" type="datetimeFigureOut">
               <a:rPr lang="en-US" smtClean="0"/>
-              <a:t>5/18/2026</a:t>
+              <a:t>9/9/2026</a:t>
             </a:fld>
             <a:endParaRPr lang="en-US"/>
           </a:p>
@@ -452,7 +458,7 @@
           <a:p>
             <a:fld id="{FBCC2567-9977-4F83-A8E1-848787B3FEC4}" type="datetimeFigureOut">
               <a:rPr lang="en-US" smtClean="0"/>
-              <a:t>5/18/2026</a:t>
+              <a:t>9/9/2026</a:t>
             </a:fld>
             <a:endParaRPr lang="en-US"/>
           </a:p>
@@ -660,7 +666,7 @@
           <a:p>
             <a:fld id="{FBCC2567-9977-4F83-A8E1-848787B3FEC4}" type="datetimeFigureOut">
               <a:rPr lang="en-US" smtClean="0"/>
-              <a:t>5/18/2026</a:t>
+              <a:t>9/9/2026</a:t>
             </a:fld>
             <a:endParaRPr lang="en-US"/>
           </a:p>
@@ -858,7 +864,7 @@
           <a:p>
             <a:fld id="{FBCC2567-9977-4F83-A8E1-848787B3FEC4}" type="datetimeFigureOut">
               <a:rPr lang="en-US" smtClean="0"/>
-              <a:t>5/18/2026</a:t>
+              <a:t>9/9/2026</a:t>
             </a:fld>
             <a:endParaRPr lang="en-US"/>
           </a:p>
@@ -1133,7 +1139,7 @@
           <a:p>
             <a:fld id="{FBCC2567-9977-4F83-A8E1-848787B3FEC4}" type="datetimeFigureOut">
               <a:rPr lang="en-US" smtClean="0"/>
-              <a:t>5/18/2026</a:t>
+              <a:t>9/9/2026</a:t>
             </a:fld>
             <a:endParaRPr lang="en-US"/>
           </a:p>
@@ -1398,7 +1404,7 @@
           <a:p>
             <a:fld id="{FBCC2567-9977-4F83-A8E1-848787B3FEC4}" type="datetimeFigureOut">
               <a:rPr lang="en-US" smtClean="0"/>
-              <a:t>5/18/2026</a:t>
+              <a:t>9/9/2026</a:t>
             </a:fld>
             <a:endParaRPr lang="en-US"/>
           </a:p>
@@ -1810,7 +1816,7 @@
           <a:p>
             <a:fld id="{FBCC2567-9977-4F83-A8E1-848787B3FEC4}" type="datetimeFigureOut">
               <a:rPr lang="en-US" smtClean="0"/>
-              <a:t>5/18/2026</a:t>
+              <a:t>9/9/2026</a:t>
             </a:fld>
             <a:endParaRPr lang="en-US"/>
           </a:p>
@@ -1951,7 +1957,7 @@
           <a:p>
             <a:fld id="{FBCC2567-9977-4F83-A8E1-848787B3FEC4}" type="datetimeFigureOut">
               <a:rPr lang="en-US" smtClean="0"/>
-              <a:t>5/18/2026</a:t>
+              <a:t>9/9/2026</a:t>
             </a:fld>
             <a:endParaRPr lang="en-US"/>
           </a:p>
@@ -2064,7 +2070,7 @@
           <a:p>
             <a:fld id="{FBCC2567-9977-4F83-A8E1-848787B3FEC4}" type="datetimeFigureOut">
               <a:rPr lang="en-US" smtClean="0"/>
-              <a:t>5/18/2026</a:t>
+              <a:t>9/9/2026</a:t>
             </a:fld>
             <a:endParaRPr lang="en-US"/>
           </a:p>
@@ -2375,7 +2381,7 @@
           <a:p>
             <a:fld id="{FBCC2567-9977-4F83-A8E1-848787B3FEC4}" type="datetimeFigureOut">
               <a:rPr lang="en-US" smtClean="0"/>
-              <a:t>5/18/2026</a:t>
+              <a:t>9/9/2026</a:t>
             </a:fld>
             <a:endParaRPr lang="en-US"/>
           </a:p>
@@ -2663,7 +2669,7 @@
           <a:p>
             <a:fld id="{FBCC2567-9977-4F83-A8E1-848787B3FEC4}" type="datetimeFigureOut">
               <a:rPr lang="en-US" smtClean="0"/>
-              <a:t>5/18/2026</a:t>
+              <a:t>9/9/2026</a:t>
             </a:fld>
             <a:endParaRPr lang="en-US"/>
           </a:p>
@@ -2904,7 +2910,7 @@
           <a:p>
             <a:fld id="{FBCC2567-9977-4F83-A8E1-848787B3FEC4}" type="datetimeFigureOut">
               <a:rPr lang="en-US" smtClean="0"/>
-              <a:t>5/18/2026</a:t>
+              <a:t>9/9/2026</a:t>
             </a:fld>
             <a:endParaRPr lang="en-US"/>
           </a:p>
@@ -3349,7 +3355,7 @@
         </p:blipFill>
         <p:spPr>
           <a:xfrm>
-            <a:off x="1998337" y="142875"/>
+            <a:off x="664837" y="90490"/>
             <a:ext cx="6811216" cy="5143500"/>
           </a:xfrm>
           <a:prstGeom prst="rect">
@@ -3385,7 +3391,7 @@
         </p:blipFill>
         <p:spPr>
           <a:xfrm>
-            <a:off x="1833559" y="3912870"/>
+            <a:off x="500059" y="3860485"/>
             <a:ext cx="7148515" cy="2859405"/>
           </a:xfrm>
           <a:prstGeom prst="rect">
@@ -3407,7 +3413,7 @@
         </p:nvSpPr>
         <p:spPr>
           <a:xfrm>
-            <a:off x="1998337" y="52387"/>
+            <a:off x="664837" y="2"/>
             <a:ext cx="1190625" cy="307777"/>
           </a:xfrm>
           <a:prstGeom prst="rect">
@@ -3442,7 +3448,7 @@
         </p:nvSpPr>
         <p:spPr>
           <a:xfrm>
-            <a:off x="4360537" y="52386"/>
+            <a:off x="3027037" y="1"/>
             <a:ext cx="1190625" cy="307777"/>
           </a:xfrm>
           <a:prstGeom prst="rect">
@@ -3477,7 +3483,7 @@
         </p:nvSpPr>
         <p:spPr>
           <a:xfrm>
-            <a:off x="6640840" y="52385"/>
+            <a:off x="5307340" y="0"/>
             <a:ext cx="1190625" cy="307777"/>
           </a:xfrm>
           <a:prstGeom prst="rect">
@@ -3512,7 +3518,7 @@
         </p:nvSpPr>
         <p:spPr>
           <a:xfrm>
-            <a:off x="1998337" y="1873985"/>
+            <a:off x="664837" y="1821600"/>
             <a:ext cx="1190625" cy="307777"/>
           </a:xfrm>
           <a:prstGeom prst="rect">
@@ -3547,7 +3553,7 @@
         </p:nvSpPr>
         <p:spPr>
           <a:xfrm>
-            <a:off x="4360537" y="1873984"/>
+            <a:off x="3027037" y="1821599"/>
             <a:ext cx="1190625" cy="307777"/>
           </a:xfrm>
           <a:prstGeom prst="rect">
@@ -3582,7 +3588,7 @@
         </p:nvSpPr>
         <p:spPr>
           <a:xfrm>
-            <a:off x="6640840" y="1873983"/>
+            <a:off x="5307340" y="1821598"/>
             <a:ext cx="1190625" cy="307777"/>
           </a:xfrm>
           <a:prstGeom prst="rect">
@@ -3617,7 +3623,7 @@
         </p:nvSpPr>
         <p:spPr>
           <a:xfrm>
-            <a:off x="1998336" y="3695583"/>
+            <a:off x="664836" y="3643198"/>
             <a:ext cx="1190625" cy="307777"/>
           </a:xfrm>
           <a:prstGeom prst="rect">
@@ -3642,6 +3648,555 @@
     <p:extLst>
       <p:ext uri="{BB962C8B-B14F-4D97-AF65-F5344CB8AC3E}">
         <p14:creationId xmlns:p14="http://schemas.microsoft.com/office/powerpoint/2010/main" val="403282770"/>
+      </p:ext>
+    </p:extLst>
+  </p:cSld>
+  <p:clrMapOvr>
+    <a:masterClrMapping/>
+  </p:clrMapOvr>
+</p:sld>
+</file>
+
+<file path=ppt/slides/slide2.xml><?xml version="1.0" encoding="utf-8"?>
+<p:sld xmlns:a="http://schemas.openxmlformats.org/drawingml/2006/main" xmlns:r="http://schemas.openxmlformats.org/officeDocument/2006/relationships" xmlns:p="http://schemas.openxmlformats.org/presentationml/2006/main">
+  <p:cSld>
+    <p:spTree>
+      <p:nvGrpSpPr>
+        <p:cNvPr id="1" name=""/>
+        <p:cNvGrpSpPr/>
+        <p:nvPr/>
+      </p:nvGrpSpPr>
+      <p:grpSpPr>
+        <a:xfrm>
+          <a:off x="0" y="0"/>
+          <a:ext cx="0" cy="0"/>
+          <a:chOff x="0" y="0"/>
+          <a:chExt cx="0" cy="0"/>
+        </a:xfrm>
+      </p:grpSpPr>
+      <p:pic>
+        <p:nvPicPr>
+          <p:cNvPr id="7" name="Picture 6">
+            <a:extLst>
+              <a:ext uri="{FF2B5EF4-FFF2-40B4-BE49-F238E27FC236}">
+                <a16:creationId xmlns:a16="http://schemas.microsoft.com/office/drawing/2014/main" id="{7C8736B8-A72E-327D-9028-782DCD453EA0}"/>
+              </a:ext>
+            </a:extLst>
+          </p:cNvPr>
+          <p:cNvPicPr>
+            <a:picLocks noChangeAspect="1"/>
+          </p:cNvPicPr>
+          <p:nvPr/>
+        </p:nvPicPr>
+        <p:blipFill>
+          <a:blip r:embed="rId2"/>
+          <a:stretch>
+            <a:fillRect/>
+          </a:stretch>
+        </p:blipFill>
+        <p:spPr>
+          <a:xfrm>
+            <a:off x="2213254" y="0"/>
+            <a:ext cx="6938825" cy="4358558"/>
+          </a:xfrm>
+          <a:prstGeom prst="rect">
+            <a:avLst/>
+          </a:prstGeom>
+        </p:spPr>
+      </p:pic>
+      <p:pic>
+        <p:nvPicPr>
+          <p:cNvPr id="9" name="Picture 8">
+            <a:extLst>
+              <a:ext uri="{FF2B5EF4-FFF2-40B4-BE49-F238E27FC236}">
+                <a16:creationId xmlns:a16="http://schemas.microsoft.com/office/drawing/2014/main" id="{03A17030-1E7C-EAC9-84D1-686267BC33AB}"/>
+              </a:ext>
+            </a:extLst>
+          </p:cNvPr>
+          <p:cNvPicPr>
+            <a:picLocks noChangeAspect="1"/>
+          </p:cNvPicPr>
+          <p:nvPr/>
+        </p:nvPicPr>
+        <p:blipFill>
+          <a:blip r:embed="rId3"/>
+          <a:srcRect b="23332"/>
+          <a:stretch>
+            <a:fillRect/>
+          </a:stretch>
+        </p:blipFill>
+        <p:spPr>
+          <a:xfrm>
+            <a:off x="1948586" y="3167744"/>
+            <a:ext cx="7195414" cy="1544425"/>
+          </a:xfrm>
+          <a:prstGeom prst="rect">
+            <a:avLst/>
+          </a:prstGeom>
+        </p:spPr>
+      </p:pic>
+      <p:pic>
+        <p:nvPicPr>
+          <p:cNvPr id="11" name="Picture 10">
+            <a:extLst>
+              <a:ext uri="{FF2B5EF4-FFF2-40B4-BE49-F238E27FC236}">
+                <a16:creationId xmlns:a16="http://schemas.microsoft.com/office/drawing/2014/main" id="{153BA0A4-0C58-EB7B-14D2-FC910BDB995D}"/>
+              </a:ext>
+            </a:extLst>
+          </p:cNvPr>
+          <p:cNvPicPr>
+            <a:picLocks noChangeAspect="1"/>
+          </p:cNvPicPr>
+          <p:nvPr/>
+        </p:nvPicPr>
+        <p:blipFill>
+          <a:blip r:embed="rId4"/>
+          <a:stretch>
+            <a:fillRect/>
+          </a:stretch>
+        </p:blipFill>
+        <p:spPr>
+          <a:xfrm>
+            <a:off x="1956665" y="4712169"/>
+            <a:ext cx="7195414" cy="1999552"/>
+          </a:xfrm>
+          <a:prstGeom prst="rect">
+            <a:avLst/>
+          </a:prstGeom>
+        </p:spPr>
+      </p:pic>
+      <p:sp>
+        <p:nvSpPr>
+          <p:cNvPr id="13" name="TextBox 12">
+            <a:extLst>
+              <a:ext uri="{FF2B5EF4-FFF2-40B4-BE49-F238E27FC236}">
+                <a16:creationId xmlns:a16="http://schemas.microsoft.com/office/drawing/2014/main" id="{91E15CBC-BD04-EC5E-F5C8-C63F77F9AF6F}"/>
+              </a:ext>
+            </a:extLst>
+          </p:cNvPr>
+          <p:cNvSpPr txBox="1"/>
+          <p:nvPr/>
+        </p:nvSpPr>
+        <p:spPr>
+          <a:xfrm>
+            <a:off x="2367190" y="-23718"/>
+            <a:ext cx="1190625" cy="246221"/>
+          </a:xfrm>
+          <a:prstGeom prst="rect">
+            <a:avLst/>
+          </a:prstGeom>
+          <a:noFill/>
+        </p:spPr>
+        <p:txBody>
+          <a:bodyPr wrap="square" rtlCol="0">
+            <a:spAutoFit/>
+          </a:bodyPr>
+          <a:lstStyle/>
+          <a:p>
+            <a:r>
+              <a:rPr lang="en-US" sz="1000" dirty="0"/>
+              <a:t>(a)</a:t>
+            </a:r>
+          </a:p>
+        </p:txBody>
+      </p:sp>
+      <p:sp>
+        <p:nvSpPr>
+          <p:cNvPr id="15" name="TextBox 14">
+            <a:extLst>
+              <a:ext uri="{FF2B5EF4-FFF2-40B4-BE49-F238E27FC236}">
+                <a16:creationId xmlns:a16="http://schemas.microsoft.com/office/drawing/2014/main" id="{1008FD0E-926E-D3D8-87E8-5015861D69B3}"/>
+              </a:ext>
+            </a:extLst>
+          </p:cNvPr>
+          <p:cNvSpPr txBox="1"/>
+          <p:nvPr/>
+        </p:nvSpPr>
+        <p:spPr>
+          <a:xfrm>
+            <a:off x="4135931" y="-27780"/>
+            <a:ext cx="1190625" cy="246221"/>
+          </a:xfrm>
+          <a:prstGeom prst="rect">
+            <a:avLst/>
+          </a:prstGeom>
+          <a:noFill/>
+        </p:spPr>
+        <p:txBody>
+          <a:bodyPr wrap="square" rtlCol="0">
+            <a:spAutoFit/>
+          </a:bodyPr>
+          <a:lstStyle/>
+          <a:p>
+            <a:r>
+              <a:rPr lang="en-US" sz="1000" dirty="0"/>
+              <a:t>(b)</a:t>
+            </a:r>
+          </a:p>
+        </p:txBody>
+      </p:sp>
+      <p:sp>
+        <p:nvSpPr>
+          <p:cNvPr id="17" name="TextBox 16">
+            <a:extLst>
+              <a:ext uri="{FF2B5EF4-FFF2-40B4-BE49-F238E27FC236}">
+                <a16:creationId xmlns:a16="http://schemas.microsoft.com/office/drawing/2014/main" id="{660AF4F0-5CFE-AE33-CB68-1393F913CE3A}"/>
+              </a:ext>
+            </a:extLst>
+          </p:cNvPr>
+          <p:cNvSpPr txBox="1"/>
+          <p:nvPr/>
+        </p:nvSpPr>
+        <p:spPr>
+          <a:xfrm>
+            <a:off x="5823597" y="-27781"/>
+            <a:ext cx="1190625" cy="246221"/>
+          </a:xfrm>
+          <a:prstGeom prst="rect">
+            <a:avLst/>
+          </a:prstGeom>
+          <a:noFill/>
+        </p:spPr>
+        <p:txBody>
+          <a:bodyPr wrap="square" rtlCol="0">
+            <a:spAutoFit/>
+          </a:bodyPr>
+          <a:lstStyle/>
+          <a:p>
+            <a:r>
+              <a:rPr lang="en-US" sz="1000" dirty="0"/>
+              <a:t>(c)</a:t>
+            </a:r>
+          </a:p>
+        </p:txBody>
+      </p:sp>
+      <p:sp>
+        <p:nvSpPr>
+          <p:cNvPr id="19" name="TextBox 18">
+            <a:extLst>
+              <a:ext uri="{FF2B5EF4-FFF2-40B4-BE49-F238E27FC236}">
+                <a16:creationId xmlns:a16="http://schemas.microsoft.com/office/drawing/2014/main" id="{E5780263-5639-8AC9-B295-DFA6611F7917}"/>
+              </a:ext>
+            </a:extLst>
+          </p:cNvPr>
+          <p:cNvSpPr txBox="1"/>
+          <p:nvPr/>
+        </p:nvSpPr>
+        <p:spPr>
+          <a:xfrm>
+            <a:off x="2367189" y="1500208"/>
+            <a:ext cx="1190625" cy="246221"/>
+          </a:xfrm>
+          <a:prstGeom prst="rect">
+            <a:avLst/>
+          </a:prstGeom>
+          <a:noFill/>
+        </p:spPr>
+        <p:txBody>
+          <a:bodyPr wrap="square" rtlCol="0">
+            <a:spAutoFit/>
+          </a:bodyPr>
+          <a:lstStyle/>
+          <a:p>
+            <a:r>
+              <a:rPr lang="en-US" sz="1000" dirty="0"/>
+              <a:t>(e)</a:t>
+            </a:r>
+          </a:p>
+        </p:txBody>
+      </p:sp>
+      <p:sp>
+        <p:nvSpPr>
+          <p:cNvPr id="21" name="TextBox 20">
+            <a:extLst>
+              <a:ext uri="{FF2B5EF4-FFF2-40B4-BE49-F238E27FC236}">
+                <a16:creationId xmlns:a16="http://schemas.microsoft.com/office/drawing/2014/main" id="{FD9BF6BE-1E62-2903-5A01-8C8D228B1EC1}"/>
+              </a:ext>
+            </a:extLst>
+          </p:cNvPr>
+          <p:cNvSpPr txBox="1"/>
+          <p:nvPr/>
+        </p:nvSpPr>
+        <p:spPr>
+          <a:xfrm>
+            <a:off x="4135930" y="1501657"/>
+            <a:ext cx="1190625" cy="246221"/>
+          </a:xfrm>
+          <a:prstGeom prst="rect">
+            <a:avLst/>
+          </a:prstGeom>
+          <a:noFill/>
+        </p:spPr>
+        <p:txBody>
+          <a:bodyPr wrap="square" rtlCol="0">
+            <a:spAutoFit/>
+          </a:bodyPr>
+          <a:lstStyle/>
+          <a:p>
+            <a:r>
+              <a:rPr lang="en-US" sz="1000" dirty="0"/>
+              <a:t>(f)</a:t>
+            </a:r>
+          </a:p>
+        </p:txBody>
+      </p:sp>
+      <p:sp>
+        <p:nvSpPr>
+          <p:cNvPr id="23" name="TextBox 22">
+            <a:extLst>
+              <a:ext uri="{FF2B5EF4-FFF2-40B4-BE49-F238E27FC236}">
+                <a16:creationId xmlns:a16="http://schemas.microsoft.com/office/drawing/2014/main" id="{F735129C-F34C-BFE3-50A3-6EC587D952E6}"/>
+              </a:ext>
+            </a:extLst>
+          </p:cNvPr>
+          <p:cNvSpPr txBox="1"/>
+          <p:nvPr/>
+        </p:nvSpPr>
+        <p:spPr>
+          <a:xfrm>
+            <a:off x="7231574" y="1797880"/>
+            <a:ext cx="1190625" cy="246221"/>
+          </a:xfrm>
+          <a:prstGeom prst="rect">
+            <a:avLst/>
+          </a:prstGeom>
+          <a:noFill/>
+        </p:spPr>
+        <p:txBody>
+          <a:bodyPr wrap="square" rtlCol="0">
+            <a:spAutoFit/>
+          </a:bodyPr>
+          <a:lstStyle/>
+          <a:p>
+            <a:r>
+              <a:rPr lang="en-US" sz="1000" dirty="0"/>
+              <a:t>(f)</a:t>
+            </a:r>
+          </a:p>
+        </p:txBody>
+      </p:sp>
+      <p:sp>
+        <p:nvSpPr>
+          <p:cNvPr id="25" name="TextBox 24">
+            <a:extLst>
+              <a:ext uri="{FF2B5EF4-FFF2-40B4-BE49-F238E27FC236}">
+                <a16:creationId xmlns:a16="http://schemas.microsoft.com/office/drawing/2014/main" id="{7182CF63-E7F3-6287-CB7C-36F5D325701F}"/>
+              </a:ext>
+            </a:extLst>
+          </p:cNvPr>
+          <p:cNvSpPr txBox="1"/>
+          <p:nvPr/>
+        </p:nvSpPr>
+        <p:spPr>
+          <a:xfrm>
+            <a:off x="2589070" y="3619480"/>
+            <a:ext cx="1190625" cy="246221"/>
+          </a:xfrm>
+          <a:prstGeom prst="rect">
+            <a:avLst/>
+          </a:prstGeom>
+          <a:noFill/>
+        </p:spPr>
+        <p:txBody>
+          <a:bodyPr wrap="square" rtlCol="0">
+            <a:spAutoFit/>
+          </a:bodyPr>
+          <a:lstStyle/>
+          <a:p>
+            <a:r>
+              <a:rPr lang="en-US" sz="1000" dirty="0"/>
+              <a:t>(g)</a:t>
+            </a:r>
+          </a:p>
+        </p:txBody>
+      </p:sp>
+      <p:sp>
+        <p:nvSpPr>
+          <p:cNvPr id="27" name="TextBox 26">
+            <a:extLst>
+              <a:ext uri="{FF2B5EF4-FFF2-40B4-BE49-F238E27FC236}">
+                <a16:creationId xmlns:a16="http://schemas.microsoft.com/office/drawing/2014/main" id="{7755BF67-46BF-B81A-B4F6-9792632C458B}"/>
+              </a:ext>
+            </a:extLst>
+          </p:cNvPr>
+          <p:cNvSpPr txBox="1"/>
+          <p:nvPr/>
+        </p:nvSpPr>
+        <p:spPr>
+          <a:xfrm>
+            <a:off x="7487838" y="-22701"/>
+            <a:ext cx="1190625" cy="246221"/>
+          </a:xfrm>
+          <a:prstGeom prst="rect">
+            <a:avLst/>
+          </a:prstGeom>
+          <a:noFill/>
+        </p:spPr>
+        <p:txBody>
+          <a:bodyPr wrap="square" rtlCol="0">
+            <a:spAutoFit/>
+          </a:bodyPr>
+          <a:lstStyle/>
+          <a:p>
+            <a:r>
+              <a:rPr lang="en-US" sz="1000" dirty="0"/>
+              <a:t>(d)</a:t>
+            </a:r>
+          </a:p>
+        </p:txBody>
+      </p:sp>
+      <p:sp>
+        <p:nvSpPr>
+          <p:cNvPr id="29" name="TextBox 28">
+            <a:extLst>
+              <a:ext uri="{FF2B5EF4-FFF2-40B4-BE49-F238E27FC236}">
+                <a16:creationId xmlns:a16="http://schemas.microsoft.com/office/drawing/2014/main" id="{1B17EFCD-5D65-0250-3D60-67C3D4007673}"/>
+              </a:ext>
+            </a:extLst>
+          </p:cNvPr>
+          <p:cNvSpPr txBox="1"/>
+          <p:nvPr/>
+        </p:nvSpPr>
+        <p:spPr>
+          <a:xfrm>
+            <a:off x="5823597" y="1500207"/>
+            <a:ext cx="1190625" cy="246221"/>
+          </a:xfrm>
+          <a:prstGeom prst="rect">
+            <a:avLst/>
+          </a:prstGeom>
+          <a:noFill/>
+        </p:spPr>
+        <p:txBody>
+          <a:bodyPr wrap="square" rtlCol="0">
+            <a:spAutoFit/>
+          </a:bodyPr>
+          <a:lstStyle/>
+          <a:p>
+            <a:r>
+              <a:rPr lang="en-US" sz="1000" dirty="0"/>
+              <a:t>(g)</a:t>
+            </a:r>
+          </a:p>
+        </p:txBody>
+      </p:sp>
+      <p:sp>
+        <p:nvSpPr>
+          <p:cNvPr id="31" name="TextBox 30">
+            <a:extLst>
+              <a:ext uri="{FF2B5EF4-FFF2-40B4-BE49-F238E27FC236}">
+                <a16:creationId xmlns:a16="http://schemas.microsoft.com/office/drawing/2014/main" id="{819BC32F-CF79-0BEE-61FA-28DB231A27C5}"/>
+              </a:ext>
+            </a:extLst>
+          </p:cNvPr>
+          <p:cNvSpPr txBox="1"/>
+          <p:nvPr/>
+        </p:nvSpPr>
+        <p:spPr>
+          <a:xfrm>
+            <a:off x="7405463" y="1497964"/>
+            <a:ext cx="1190625" cy="246221"/>
+          </a:xfrm>
+          <a:prstGeom prst="rect">
+            <a:avLst/>
+          </a:prstGeom>
+          <a:noFill/>
+        </p:spPr>
+        <p:txBody>
+          <a:bodyPr wrap="square" rtlCol="0">
+            <a:spAutoFit/>
+          </a:bodyPr>
+          <a:lstStyle/>
+          <a:p>
+            <a:r>
+              <a:rPr lang="en-US" sz="1000" dirty="0"/>
+              <a:t>(h)</a:t>
+            </a:r>
+          </a:p>
+        </p:txBody>
+      </p:sp>
+      <p:sp>
+        <p:nvSpPr>
+          <p:cNvPr id="33" name="TextBox 32">
+            <a:extLst>
+              <a:ext uri="{FF2B5EF4-FFF2-40B4-BE49-F238E27FC236}">
+                <a16:creationId xmlns:a16="http://schemas.microsoft.com/office/drawing/2014/main" id="{CE736E46-609C-35AF-6E70-84747FF80154}"/>
+              </a:ext>
+            </a:extLst>
+          </p:cNvPr>
+          <p:cNvSpPr txBox="1"/>
+          <p:nvPr/>
+        </p:nvSpPr>
+        <p:spPr>
+          <a:xfrm>
+            <a:off x="2367190" y="3003512"/>
+            <a:ext cx="299810" cy="246221"/>
+          </a:xfrm>
+          <a:prstGeom prst="rect">
+            <a:avLst/>
+          </a:prstGeom>
+          <a:noFill/>
+        </p:spPr>
+        <p:txBody>
+          <a:bodyPr wrap="square" rtlCol="0">
+            <a:spAutoFit/>
+          </a:bodyPr>
+          <a:lstStyle/>
+          <a:p>
+            <a:r>
+              <a:rPr lang="en-US" sz="1000" dirty="0"/>
+              <a:t>(</a:t>
+            </a:r>
+            <a:r>
+              <a:rPr lang="en-US" sz="1000" dirty="0" err="1"/>
+              <a:t>i</a:t>
+            </a:r>
+            <a:r>
+              <a:rPr lang="en-US" sz="1000" dirty="0"/>
+              <a:t>)</a:t>
+            </a:r>
+          </a:p>
+        </p:txBody>
+      </p:sp>
+      <p:sp>
+        <p:nvSpPr>
+          <p:cNvPr id="35" name="TextBox 34">
+            <a:extLst>
+              <a:ext uri="{FF2B5EF4-FFF2-40B4-BE49-F238E27FC236}">
+                <a16:creationId xmlns:a16="http://schemas.microsoft.com/office/drawing/2014/main" id="{868F768C-7FEA-6A58-ABEF-ABE24C36EEFF}"/>
+              </a:ext>
+            </a:extLst>
+          </p:cNvPr>
+          <p:cNvSpPr txBox="1"/>
+          <p:nvPr/>
+        </p:nvSpPr>
+        <p:spPr>
+          <a:xfrm>
+            <a:off x="2321356" y="4589058"/>
+            <a:ext cx="345643" cy="246221"/>
+          </a:xfrm>
+          <a:prstGeom prst="rect">
+            <a:avLst/>
+          </a:prstGeom>
+          <a:noFill/>
+        </p:spPr>
+        <p:txBody>
+          <a:bodyPr wrap="square" rtlCol="0">
+            <a:spAutoFit/>
+          </a:bodyPr>
+          <a:lstStyle/>
+          <a:p>
+            <a:r>
+              <a:rPr lang="en-US" sz="1000" dirty="0"/>
+              <a:t>(j)</a:t>
+            </a:r>
+          </a:p>
+        </p:txBody>
+      </p:sp>
+    </p:spTree>
+    <p:extLst>
+      <p:ext uri="{BB962C8B-B14F-4D97-AF65-F5344CB8AC3E}">
+        <p14:creationId xmlns:p14="http://schemas.microsoft.com/office/powerpoint/2010/main" val="3949165652"/>
       </p:ext>
     </p:extLst>
   </p:cSld>

</xml_diff>

<commit_message>
update figure 8 for new paper version
</commit_message>
<xml_diff>
--- a/figure8/fig8_prelim.pptx
+++ b/figure8/fig8_prelim.pptx
@@ -7,6 +7,7 @@
   <p:sldIdLst>
     <p:sldId id="256" r:id="rId2"/>
     <p:sldId id="257" r:id="rId3"/>
+    <p:sldId id="258" r:id="rId4"/>
   </p:sldIdLst>
   <p:sldSz cx="12192000" cy="6858000"/>
   <p:notesSz cx="6858000" cy="9144000"/>
@@ -260,7 +261,7 @@
           <a:p>
             <a:fld id="{FBCC2567-9977-4F83-A8E1-848787B3FEC4}" type="datetimeFigureOut">
               <a:rPr lang="en-US" smtClean="0"/>
-              <a:t>9/9/2026</a:t>
+              <a:t>10/7/2026</a:t>
             </a:fld>
             <a:endParaRPr lang="en-US"/>
           </a:p>
@@ -458,7 +459,7 @@
           <a:p>
             <a:fld id="{FBCC2567-9977-4F83-A8E1-848787B3FEC4}" type="datetimeFigureOut">
               <a:rPr lang="en-US" smtClean="0"/>
-              <a:t>9/9/2026</a:t>
+              <a:t>10/7/2026</a:t>
             </a:fld>
             <a:endParaRPr lang="en-US"/>
           </a:p>
@@ -666,7 +667,7 @@
           <a:p>
             <a:fld id="{FBCC2567-9977-4F83-A8E1-848787B3FEC4}" type="datetimeFigureOut">
               <a:rPr lang="en-US" smtClean="0"/>
-              <a:t>9/9/2026</a:t>
+              <a:t>10/7/2026</a:t>
             </a:fld>
             <a:endParaRPr lang="en-US"/>
           </a:p>
@@ -864,7 +865,7 @@
           <a:p>
             <a:fld id="{FBCC2567-9977-4F83-A8E1-848787B3FEC4}" type="datetimeFigureOut">
               <a:rPr lang="en-US" smtClean="0"/>
-              <a:t>9/9/2026</a:t>
+              <a:t>10/7/2026</a:t>
             </a:fld>
             <a:endParaRPr lang="en-US"/>
           </a:p>
@@ -1139,7 +1140,7 @@
           <a:p>
             <a:fld id="{FBCC2567-9977-4F83-A8E1-848787B3FEC4}" type="datetimeFigureOut">
               <a:rPr lang="en-US" smtClean="0"/>
-              <a:t>9/9/2026</a:t>
+              <a:t>10/7/2026</a:t>
             </a:fld>
             <a:endParaRPr lang="en-US"/>
           </a:p>
@@ -1404,7 +1405,7 @@
           <a:p>
             <a:fld id="{FBCC2567-9977-4F83-A8E1-848787B3FEC4}" type="datetimeFigureOut">
               <a:rPr lang="en-US" smtClean="0"/>
-              <a:t>9/9/2026</a:t>
+              <a:t>10/7/2026</a:t>
             </a:fld>
             <a:endParaRPr lang="en-US"/>
           </a:p>
@@ -1816,7 +1817,7 @@
           <a:p>
             <a:fld id="{FBCC2567-9977-4F83-A8E1-848787B3FEC4}" type="datetimeFigureOut">
               <a:rPr lang="en-US" smtClean="0"/>
-              <a:t>9/9/2026</a:t>
+              <a:t>10/7/2026</a:t>
             </a:fld>
             <a:endParaRPr lang="en-US"/>
           </a:p>
@@ -1957,7 +1958,7 @@
           <a:p>
             <a:fld id="{FBCC2567-9977-4F83-A8E1-848787B3FEC4}" type="datetimeFigureOut">
               <a:rPr lang="en-US" smtClean="0"/>
-              <a:t>9/9/2026</a:t>
+              <a:t>10/7/2026</a:t>
             </a:fld>
             <a:endParaRPr lang="en-US"/>
           </a:p>
@@ -2070,7 +2071,7 @@
           <a:p>
             <a:fld id="{FBCC2567-9977-4F83-A8E1-848787B3FEC4}" type="datetimeFigureOut">
               <a:rPr lang="en-US" smtClean="0"/>
-              <a:t>9/9/2026</a:t>
+              <a:t>10/7/2026</a:t>
             </a:fld>
             <a:endParaRPr lang="en-US"/>
           </a:p>
@@ -2381,7 +2382,7 @@
           <a:p>
             <a:fld id="{FBCC2567-9977-4F83-A8E1-848787B3FEC4}" type="datetimeFigureOut">
               <a:rPr lang="en-US" smtClean="0"/>
-              <a:t>9/9/2026</a:t>
+              <a:t>10/7/2026</a:t>
             </a:fld>
             <a:endParaRPr lang="en-US"/>
           </a:p>
@@ -2669,7 +2670,7 @@
           <a:p>
             <a:fld id="{FBCC2567-9977-4F83-A8E1-848787B3FEC4}" type="datetimeFigureOut">
               <a:rPr lang="en-US" smtClean="0"/>
-              <a:t>9/9/2026</a:t>
+              <a:t>10/7/2026</a:t>
             </a:fld>
             <a:endParaRPr lang="en-US"/>
           </a:p>
@@ -2910,7 +2911,7 @@
           <a:p>
             <a:fld id="{FBCC2567-9977-4F83-A8E1-848787B3FEC4}" type="datetimeFigureOut">
               <a:rPr lang="en-US" smtClean="0"/>
-              <a:t>9/9/2026</a:t>
+              <a:t>10/7/2026</a:t>
             </a:fld>
             <a:endParaRPr lang="en-US"/>
           </a:p>
@@ -3757,7 +3758,7 @@
         </p:blipFill>
         <p:spPr>
           <a:xfrm>
-            <a:off x="1956665" y="4712169"/>
+            <a:off x="1956665" y="4836036"/>
             <a:ext cx="7195414" cy="1999552"/>
           </a:xfrm>
           <a:prstGeom prst="rect">
@@ -4197,6 +4198,509 @@
     <p:extLst>
       <p:ext uri="{BB962C8B-B14F-4D97-AF65-F5344CB8AC3E}">
         <p14:creationId xmlns:p14="http://schemas.microsoft.com/office/powerpoint/2010/main" val="3949165652"/>
+      </p:ext>
+    </p:extLst>
+  </p:cSld>
+  <p:clrMapOvr>
+    <a:masterClrMapping/>
+  </p:clrMapOvr>
+</p:sld>
+</file>
+
+<file path=ppt/slides/slide3.xml><?xml version="1.0" encoding="utf-8"?>
+<p:sld xmlns:a="http://schemas.openxmlformats.org/drawingml/2006/main" xmlns:r="http://schemas.openxmlformats.org/officeDocument/2006/relationships" xmlns:p="http://schemas.openxmlformats.org/presentationml/2006/main">
+  <p:cSld>
+    <p:spTree>
+      <p:nvGrpSpPr>
+        <p:cNvPr id="1" name="">
+          <a:extLst>
+            <a:ext uri="{FF2B5EF4-FFF2-40B4-BE49-F238E27FC236}">
+              <a16:creationId xmlns:a16="http://schemas.microsoft.com/office/drawing/2014/main" id="{F8FCDA00-8BC8-9D3E-56CF-8DE6DFA2A8DD}"/>
+            </a:ext>
+          </a:extLst>
+        </p:cNvPr>
+        <p:cNvGrpSpPr/>
+        <p:nvPr/>
+      </p:nvGrpSpPr>
+      <p:grpSpPr>
+        <a:xfrm>
+          <a:off x="0" y="0"/>
+          <a:ext cx="0" cy="0"/>
+          <a:chOff x="0" y="0"/>
+          <a:chExt cx="0" cy="0"/>
+        </a:xfrm>
+      </p:grpSpPr>
+      <p:pic>
+        <p:nvPicPr>
+          <p:cNvPr id="4" name="Picture 3">
+            <a:extLst>
+              <a:ext uri="{FF2B5EF4-FFF2-40B4-BE49-F238E27FC236}">
+                <a16:creationId xmlns:a16="http://schemas.microsoft.com/office/drawing/2014/main" id="{10FDE335-1739-5358-B0C8-3ED6FBD4A80A}"/>
+              </a:ext>
+            </a:extLst>
+          </p:cNvPr>
+          <p:cNvPicPr>
+            <a:picLocks noChangeAspect="1"/>
+          </p:cNvPicPr>
+          <p:nvPr/>
+        </p:nvPicPr>
+        <p:blipFill>
+          <a:blip r:embed="rId2">
+            <a:extLst>
+              <a:ext uri="{28A0092B-C50C-407E-A947-70E740481C1C}">
+                <a14:useLocalDpi xmlns:a14="http://schemas.microsoft.com/office/drawing/2010/main" val="0"/>
+              </a:ext>
+            </a:extLst>
+          </a:blip>
+          <a:stretch>
+            <a:fillRect/>
+          </a:stretch>
+        </p:blipFill>
+        <p:spPr>
+          <a:xfrm>
+            <a:off x="2198916" y="0"/>
+            <a:ext cx="6872656" cy="4327271"/>
+          </a:xfrm>
+          <a:prstGeom prst="rect">
+            <a:avLst/>
+          </a:prstGeom>
+        </p:spPr>
+      </p:pic>
+      <p:pic>
+        <p:nvPicPr>
+          <p:cNvPr id="30" name="Picture 29">
+            <a:extLst>
+              <a:ext uri="{FF2B5EF4-FFF2-40B4-BE49-F238E27FC236}">
+                <a16:creationId xmlns:a16="http://schemas.microsoft.com/office/drawing/2014/main" id="{BC7CFA25-D1E4-704D-2B26-FB81BA30B125}"/>
+              </a:ext>
+            </a:extLst>
+          </p:cNvPr>
+          <p:cNvPicPr>
+            <a:picLocks noChangeAspect="1"/>
+          </p:cNvPicPr>
+          <p:nvPr/>
+        </p:nvPicPr>
+        <p:blipFill>
+          <a:blip r:embed="rId3">
+            <a:extLst>
+              <a:ext uri="{28A0092B-C50C-407E-A947-70E740481C1C}">
+                <a14:useLocalDpi xmlns:a14="http://schemas.microsoft.com/office/drawing/2010/main" val="0"/>
+              </a:ext>
+            </a:extLst>
+          </a:blip>
+          <a:srcRect b="24445"/>
+          <a:stretch>
+            <a:fillRect/>
+          </a:stretch>
+        </p:blipFill>
+        <p:spPr>
+          <a:xfrm>
+            <a:off x="2084610" y="3262859"/>
+            <a:ext cx="6872656" cy="1557801"/>
+          </a:xfrm>
+          <a:prstGeom prst="rect">
+            <a:avLst/>
+          </a:prstGeom>
+        </p:spPr>
+      </p:pic>
+      <p:sp>
+        <p:nvSpPr>
+          <p:cNvPr id="13" name="TextBox 12">
+            <a:extLst>
+              <a:ext uri="{FF2B5EF4-FFF2-40B4-BE49-F238E27FC236}">
+                <a16:creationId xmlns:a16="http://schemas.microsoft.com/office/drawing/2014/main" id="{DD9C32F5-DE65-F895-6D08-1C7A6B5EF628}"/>
+              </a:ext>
+            </a:extLst>
+          </p:cNvPr>
+          <p:cNvSpPr txBox="1"/>
+          <p:nvPr/>
+        </p:nvSpPr>
+        <p:spPr>
+          <a:xfrm>
+            <a:off x="2367190" y="-46419"/>
+            <a:ext cx="1190625" cy="246221"/>
+          </a:xfrm>
+          <a:prstGeom prst="rect">
+            <a:avLst/>
+          </a:prstGeom>
+          <a:noFill/>
+        </p:spPr>
+        <p:txBody>
+          <a:bodyPr wrap="square" rtlCol="0">
+            <a:spAutoFit/>
+          </a:bodyPr>
+          <a:lstStyle/>
+          <a:p>
+            <a:r>
+              <a:rPr lang="en-US" sz="1000" dirty="0"/>
+              <a:t>(a)</a:t>
+            </a:r>
+          </a:p>
+        </p:txBody>
+      </p:sp>
+      <p:sp>
+        <p:nvSpPr>
+          <p:cNvPr id="15" name="TextBox 14">
+            <a:extLst>
+              <a:ext uri="{FF2B5EF4-FFF2-40B4-BE49-F238E27FC236}">
+                <a16:creationId xmlns:a16="http://schemas.microsoft.com/office/drawing/2014/main" id="{FD795E09-52F2-BA2E-C3D7-C56285D46FAC}"/>
+              </a:ext>
+            </a:extLst>
+          </p:cNvPr>
+          <p:cNvSpPr txBox="1"/>
+          <p:nvPr/>
+        </p:nvSpPr>
+        <p:spPr>
+          <a:xfrm>
+            <a:off x="4135931" y="-50481"/>
+            <a:ext cx="1190625" cy="246221"/>
+          </a:xfrm>
+          <a:prstGeom prst="rect">
+            <a:avLst/>
+          </a:prstGeom>
+          <a:noFill/>
+        </p:spPr>
+        <p:txBody>
+          <a:bodyPr wrap="square" rtlCol="0">
+            <a:spAutoFit/>
+          </a:bodyPr>
+          <a:lstStyle/>
+          <a:p>
+            <a:r>
+              <a:rPr lang="en-US" sz="1000" dirty="0"/>
+              <a:t>(b)</a:t>
+            </a:r>
+          </a:p>
+        </p:txBody>
+      </p:sp>
+      <p:sp>
+        <p:nvSpPr>
+          <p:cNvPr id="17" name="TextBox 16">
+            <a:extLst>
+              <a:ext uri="{FF2B5EF4-FFF2-40B4-BE49-F238E27FC236}">
+                <a16:creationId xmlns:a16="http://schemas.microsoft.com/office/drawing/2014/main" id="{E520C301-7B71-EBBF-9B5A-865328F2B704}"/>
+              </a:ext>
+            </a:extLst>
+          </p:cNvPr>
+          <p:cNvSpPr txBox="1"/>
+          <p:nvPr/>
+        </p:nvSpPr>
+        <p:spPr>
+          <a:xfrm>
+            <a:off x="5823597" y="-50482"/>
+            <a:ext cx="1190625" cy="246221"/>
+          </a:xfrm>
+          <a:prstGeom prst="rect">
+            <a:avLst/>
+          </a:prstGeom>
+          <a:noFill/>
+        </p:spPr>
+        <p:txBody>
+          <a:bodyPr wrap="square" rtlCol="0">
+            <a:spAutoFit/>
+          </a:bodyPr>
+          <a:lstStyle/>
+          <a:p>
+            <a:r>
+              <a:rPr lang="en-US" sz="1000" dirty="0"/>
+              <a:t>(c)</a:t>
+            </a:r>
+          </a:p>
+        </p:txBody>
+      </p:sp>
+      <p:sp>
+        <p:nvSpPr>
+          <p:cNvPr id="19" name="TextBox 18">
+            <a:extLst>
+              <a:ext uri="{FF2B5EF4-FFF2-40B4-BE49-F238E27FC236}">
+                <a16:creationId xmlns:a16="http://schemas.microsoft.com/office/drawing/2014/main" id="{5100C4D9-E3BA-3E8B-787C-FA674D41220C}"/>
+              </a:ext>
+            </a:extLst>
+          </p:cNvPr>
+          <p:cNvSpPr txBox="1"/>
+          <p:nvPr/>
+        </p:nvSpPr>
+        <p:spPr>
+          <a:xfrm>
+            <a:off x="2367189" y="1477507"/>
+            <a:ext cx="1190625" cy="246221"/>
+          </a:xfrm>
+          <a:prstGeom prst="rect">
+            <a:avLst/>
+          </a:prstGeom>
+          <a:noFill/>
+        </p:spPr>
+        <p:txBody>
+          <a:bodyPr wrap="square" rtlCol="0">
+            <a:spAutoFit/>
+          </a:bodyPr>
+          <a:lstStyle/>
+          <a:p>
+            <a:r>
+              <a:rPr lang="en-US" sz="1000" dirty="0"/>
+              <a:t>(e)</a:t>
+            </a:r>
+          </a:p>
+        </p:txBody>
+      </p:sp>
+      <p:sp>
+        <p:nvSpPr>
+          <p:cNvPr id="21" name="TextBox 20">
+            <a:extLst>
+              <a:ext uri="{FF2B5EF4-FFF2-40B4-BE49-F238E27FC236}">
+                <a16:creationId xmlns:a16="http://schemas.microsoft.com/office/drawing/2014/main" id="{6632D1C3-5EA8-57A4-7B7A-9C660E92FC9A}"/>
+              </a:ext>
+            </a:extLst>
+          </p:cNvPr>
+          <p:cNvSpPr txBox="1"/>
+          <p:nvPr/>
+        </p:nvSpPr>
+        <p:spPr>
+          <a:xfrm>
+            <a:off x="4135930" y="1478956"/>
+            <a:ext cx="1190625" cy="246221"/>
+          </a:xfrm>
+          <a:prstGeom prst="rect">
+            <a:avLst/>
+          </a:prstGeom>
+          <a:noFill/>
+        </p:spPr>
+        <p:txBody>
+          <a:bodyPr wrap="square" rtlCol="0">
+            <a:spAutoFit/>
+          </a:bodyPr>
+          <a:lstStyle/>
+          <a:p>
+            <a:r>
+              <a:rPr lang="en-US" sz="1000" dirty="0"/>
+              <a:t>(f)</a:t>
+            </a:r>
+          </a:p>
+        </p:txBody>
+      </p:sp>
+      <p:sp>
+        <p:nvSpPr>
+          <p:cNvPr id="27" name="TextBox 26">
+            <a:extLst>
+              <a:ext uri="{FF2B5EF4-FFF2-40B4-BE49-F238E27FC236}">
+                <a16:creationId xmlns:a16="http://schemas.microsoft.com/office/drawing/2014/main" id="{453849B4-4D1A-546F-C51C-CF4C49E24A67}"/>
+              </a:ext>
+            </a:extLst>
+          </p:cNvPr>
+          <p:cNvSpPr txBox="1"/>
+          <p:nvPr/>
+        </p:nvSpPr>
+        <p:spPr>
+          <a:xfrm>
+            <a:off x="7487838" y="-45402"/>
+            <a:ext cx="1190625" cy="246221"/>
+          </a:xfrm>
+          <a:prstGeom prst="rect">
+            <a:avLst/>
+          </a:prstGeom>
+          <a:noFill/>
+        </p:spPr>
+        <p:txBody>
+          <a:bodyPr wrap="square" rtlCol="0">
+            <a:spAutoFit/>
+          </a:bodyPr>
+          <a:lstStyle/>
+          <a:p>
+            <a:r>
+              <a:rPr lang="en-US" sz="1000" dirty="0"/>
+              <a:t>(d)</a:t>
+            </a:r>
+          </a:p>
+        </p:txBody>
+      </p:sp>
+      <p:sp>
+        <p:nvSpPr>
+          <p:cNvPr id="29" name="TextBox 28">
+            <a:extLst>
+              <a:ext uri="{FF2B5EF4-FFF2-40B4-BE49-F238E27FC236}">
+                <a16:creationId xmlns:a16="http://schemas.microsoft.com/office/drawing/2014/main" id="{E951101F-7691-0DC6-898F-E43B1F03DE66}"/>
+              </a:ext>
+            </a:extLst>
+          </p:cNvPr>
+          <p:cNvSpPr txBox="1"/>
+          <p:nvPr/>
+        </p:nvSpPr>
+        <p:spPr>
+          <a:xfrm>
+            <a:off x="5823597" y="1477506"/>
+            <a:ext cx="1190625" cy="246221"/>
+          </a:xfrm>
+          <a:prstGeom prst="rect">
+            <a:avLst/>
+          </a:prstGeom>
+          <a:noFill/>
+        </p:spPr>
+        <p:txBody>
+          <a:bodyPr wrap="square" rtlCol="0">
+            <a:spAutoFit/>
+          </a:bodyPr>
+          <a:lstStyle/>
+          <a:p>
+            <a:r>
+              <a:rPr lang="en-US" sz="1000" dirty="0"/>
+              <a:t>(g)</a:t>
+            </a:r>
+          </a:p>
+        </p:txBody>
+      </p:sp>
+      <p:sp>
+        <p:nvSpPr>
+          <p:cNvPr id="31" name="TextBox 30">
+            <a:extLst>
+              <a:ext uri="{FF2B5EF4-FFF2-40B4-BE49-F238E27FC236}">
+                <a16:creationId xmlns:a16="http://schemas.microsoft.com/office/drawing/2014/main" id="{9091BD1D-E1D0-D35C-BFC1-ED3C0CAA9B1F}"/>
+              </a:ext>
+            </a:extLst>
+          </p:cNvPr>
+          <p:cNvSpPr txBox="1"/>
+          <p:nvPr/>
+        </p:nvSpPr>
+        <p:spPr>
+          <a:xfrm>
+            <a:off x="7487837" y="1477505"/>
+            <a:ext cx="1190625" cy="246221"/>
+          </a:xfrm>
+          <a:prstGeom prst="rect">
+            <a:avLst/>
+          </a:prstGeom>
+          <a:noFill/>
+        </p:spPr>
+        <p:txBody>
+          <a:bodyPr wrap="square" rtlCol="0">
+            <a:spAutoFit/>
+          </a:bodyPr>
+          <a:lstStyle/>
+          <a:p>
+            <a:r>
+              <a:rPr lang="en-US" sz="1000" dirty="0"/>
+              <a:t>(h)</a:t>
+            </a:r>
+          </a:p>
+        </p:txBody>
+      </p:sp>
+      <p:sp>
+        <p:nvSpPr>
+          <p:cNvPr id="33" name="TextBox 32">
+            <a:extLst>
+              <a:ext uri="{FF2B5EF4-FFF2-40B4-BE49-F238E27FC236}">
+                <a16:creationId xmlns:a16="http://schemas.microsoft.com/office/drawing/2014/main" id="{9494D11B-C39C-0508-F828-70CA9FD274E1}"/>
+              </a:ext>
+            </a:extLst>
+          </p:cNvPr>
+          <p:cNvSpPr txBox="1"/>
+          <p:nvPr/>
+        </p:nvSpPr>
+        <p:spPr>
+          <a:xfrm>
+            <a:off x="2367189" y="3201235"/>
+            <a:ext cx="299810" cy="246221"/>
+          </a:xfrm>
+          <a:prstGeom prst="rect">
+            <a:avLst/>
+          </a:prstGeom>
+          <a:noFill/>
+        </p:spPr>
+        <p:txBody>
+          <a:bodyPr wrap="square" rtlCol="0">
+            <a:spAutoFit/>
+          </a:bodyPr>
+          <a:lstStyle/>
+          <a:p>
+            <a:r>
+              <a:rPr lang="en-US" sz="1000" dirty="0"/>
+              <a:t>(</a:t>
+            </a:r>
+            <a:r>
+              <a:rPr lang="en-US" sz="1000" dirty="0" err="1"/>
+              <a:t>i</a:t>
+            </a:r>
+            <a:r>
+              <a:rPr lang="en-US" sz="1000" dirty="0"/>
+              <a:t>)</a:t>
+            </a:r>
+          </a:p>
+        </p:txBody>
+      </p:sp>
+      <p:pic>
+        <p:nvPicPr>
+          <p:cNvPr id="34" name="Picture 33">
+            <a:extLst>
+              <a:ext uri="{FF2B5EF4-FFF2-40B4-BE49-F238E27FC236}">
+                <a16:creationId xmlns:a16="http://schemas.microsoft.com/office/drawing/2014/main" id="{AD6CF629-FDB0-F122-F23C-DF532764ECC5}"/>
+              </a:ext>
+            </a:extLst>
+          </p:cNvPr>
+          <p:cNvPicPr>
+            <a:picLocks noChangeAspect="1"/>
+          </p:cNvPicPr>
+          <p:nvPr/>
+        </p:nvPicPr>
+        <p:blipFill>
+          <a:blip r:embed="rId4">
+            <a:extLst>
+              <a:ext uri="{28A0092B-C50C-407E-A947-70E740481C1C}">
+                <a14:useLocalDpi xmlns:a14="http://schemas.microsoft.com/office/drawing/2010/main" val="0"/>
+              </a:ext>
+            </a:extLst>
+          </a:blip>
+          <a:stretch>
+            <a:fillRect/>
+          </a:stretch>
+        </p:blipFill>
+        <p:spPr>
+          <a:xfrm>
+            <a:off x="2084610" y="4835468"/>
+            <a:ext cx="6863229" cy="2058969"/>
+          </a:xfrm>
+          <a:prstGeom prst="rect">
+            <a:avLst/>
+          </a:prstGeom>
+        </p:spPr>
+      </p:pic>
+      <p:sp>
+        <p:nvSpPr>
+          <p:cNvPr id="35" name="TextBox 34">
+            <a:extLst>
+              <a:ext uri="{FF2B5EF4-FFF2-40B4-BE49-F238E27FC236}">
+                <a16:creationId xmlns:a16="http://schemas.microsoft.com/office/drawing/2014/main" id="{33BE0372-D870-7C4C-9992-728F38C0B229}"/>
+              </a:ext>
+            </a:extLst>
+          </p:cNvPr>
+          <p:cNvSpPr txBox="1"/>
+          <p:nvPr/>
+        </p:nvSpPr>
+        <p:spPr>
+          <a:xfrm>
+            <a:off x="2344272" y="4801852"/>
+            <a:ext cx="345643" cy="246221"/>
+          </a:xfrm>
+          <a:prstGeom prst="rect">
+            <a:avLst/>
+          </a:prstGeom>
+          <a:noFill/>
+        </p:spPr>
+        <p:txBody>
+          <a:bodyPr wrap="square" rtlCol="0">
+            <a:spAutoFit/>
+          </a:bodyPr>
+          <a:lstStyle/>
+          <a:p>
+            <a:r>
+              <a:rPr lang="en-US" sz="1000" dirty="0"/>
+              <a:t>(j)</a:t>
+            </a:r>
+          </a:p>
+        </p:txBody>
+      </p:sp>
+    </p:spTree>
+    <p:extLst>
+      <p:ext uri="{BB962C8B-B14F-4D97-AF65-F5344CB8AC3E}">
+        <p14:creationId xmlns:p14="http://schemas.microsoft.com/office/powerpoint/2010/main" val="2520358466"/>
       </p:ext>
     </p:extLst>
   </p:cSld>

</xml_diff>